<commit_message>
Fix SLAKE closed-question scoring: 61 non-yes/no gold answers were free points
Closed accuracy for instruction-tuned adapters was inflated 4-5 points.
Adds medvlm.metrics.closed_score and scripts/rescore_slake.py (recomputes
from stored predictions), rescoring all results, figures, report, weekly
page, talk script and deck. Conclusions unchanged; SFT gain is +17.8.
</commit_message>
<xml_diff>
--- a/docs/weekly/week1/Topic6_WeeklyReport.pptx
+++ b/docs/weekly/week1/Topic6_WeeklyReport.pptx
@@ -3185,7 +3185,7 @@
                 </a:solidFill>
                 <a:latin typeface="Noto Serif SC"/>
               </a:rPr>
-              <a:t>SFT 涨了 22 分，</a:t>
+              <a:t>SFT 涨了 18 分，</a:t>
             </a:r>
             <a:r>
               <a:rPr sz="5600" b="1">
@@ -3329,7 +3329,7 @@
                 </a:solidFill>
                 <a:latin typeface="Consolas"/>
               </a:rPr>
-              <a:t>89.2</a:t>
+              <a:t>85.1</a:t>
             </a:r>
             <a:r>
               <a:rPr sz="1300" b="0">
@@ -4528,7 +4528,7 @@
                 </a:solidFill>
                 <a:latin typeface="Consolas"/>
               </a:rPr>
-              <a:t>+21.9</a:t>
+              <a:t>+17.8</a:t>
             </a:r>
             <a:r>
               <a:rPr sz="1100" b="0">
@@ -7918,7 +7918,7 @@
                 </a:solidFill>
                 <a:latin typeface="Noto Sans SC"/>
               </a:rPr>
-              <a:t> 只评估、永不训练；切分文件固定入库；受控数据不进 git。</a:t>
+              <a:t> 只评估、永不训练。2026-09-19 修正评分：封闭题里 61 道标准答案非是非（Lung / T2 等），原折叠式评分让它们白得分，三个微调模型各高估 4–5 分，现已按字面比，本页为修正后数字。</a:t>
             </a:r>
           </a:p>
         </p:txBody>
@@ -8684,7 +8684,7 @@
                 </a:solidFill>
                 <a:latin typeface="Noto Serif SC"/>
               </a:rPr>
-              <a:t>A：只做 SFT，涨 22 分</a:t>
+              <a:t>A：只做 SFT，涨 18 分</a:t>
             </a:r>
           </a:p>
         </p:txBody>
@@ -8726,7 +8726,7 @@
                 </a:solidFill>
                 <a:latin typeface="Noto Sans SC"/>
               </a:rPr>
-              <a:t>4,919 道 SLAKE 题做三遍，4 小时 28 分。封闭题 67.3 → 89.2，开放题 recall 46.7 → 82.2。逐题看，修正 345 题，新错 30 题。</a:t>
+              <a:t>4,919 道 SLAKE 题做三遍，4 小时 28 分。封闭题 67.3 → 85.1，开放题 recall 46.7 → 82.2。逐题看，修正 328 题，新错 30 题。</a:t>
             </a:r>
           </a:p>
         </p:txBody>
@@ -9318,7 +9318,7 @@
                 </a:solidFill>
                 <a:latin typeface="Noto Sans SC"/>
               </a:rPr>
-              <a:t>SLAKE 与 A 的差异全部在 ±0.6 以内，逐题互换 15 对 14，是随机波动。文本 CPT 没有跨过模态，只帮到了自己的领域：PubMedQA 70.6 → 72.8。</a:t>
+              <a:t>SLAKE 与 A 的差异全部在 ±0.6 以内，逐题互换 15 对 17，是随机波动。文本 CPT 没有跨过模态，只帮到了自己的领域：PubMedQA 70.6 → 72.8。</a:t>
             </a:r>
           </a:p>
         </p:txBody>
@@ -9534,7 +9534,7 @@
                 </a:solidFill>
                 <a:latin typeface="Noto Sans SC"/>
               </a:rPr>
-              <a:t>封闭题 88.7 与 B1 持平，开放题略低 −0.6，逐题修正 11 题、新错 18 题。图文 CPT 同样没有增益。</a:t>
+              <a:t>封闭题 84.1 与 B1 持平，开放题略低 −0.6，逐题修正 13 题、新错 22 题。图文 CPT 同样没有增益。</a:t>
             </a:r>
           </a:p>
         </p:txBody>
@@ -10342,7 +10342,7 @@
                 </a:solidFill>
                 <a:latin typeface="Noto Sans SC"/>
               </a:rPr>
-              <a:t>器官、知识图谱、颜色、平面这些题型，基座只有 22 到 40 分。不是看不懂，是答法不对。SFT 把它们一口气拉到 85 到 100，这是词表和格式的对齐。</a:t>
+              <a:t>器官、知识图谱、颜色、平面这些题型，基座只有 22 到 40 分。不是看不懂，是答法不对。SFT 把它们一口气拉到 83 到 100，这是词表和格式的对齐。</a:t>
             </a:r>
           </a:p>
         </p:txBody>

</xml_diff>